<commit_message>
changes in the presentation
</commit_message>
<xml_diff>
--- a/presentation/HatefulMemes_FinalDemo.pptx
+++ b/presentation/HatefulMemes_FinalDemo.pptx
@@ -313,7 +313,7 @@
           <a:p>
             <a:fld id="{5BCAD085-E8A6-8845-BD4E-CB4CCA059FC4}" type="datetimeFigureOut">
               <a:rPr lang="en-US" smtClean="0"/>
-              <a:t>4/19/2026</a:t>
+              <a:t>4/25/2026</a:t>
             </a:fld>
             <a:endParaRPr lang="en-US"/>
           </a:p>
@@ -481,7 +481,7 @@
           <a:p>
             <a:fld id="{5BCAD085-E8A6-8845-BD4E-CB4CCA059FC4}" type="datetimeFigureOut">
               <a:rPr lang="en-US" smtClean="0"/>
-              <a:t>4/19/2026</a:t>
+              <a:t>4/25/2026</a:t>
             </a:fld>
             <a:endParaRPr lang="en-US"/>
           </a:p>
@@ -659,7 +659,7 @@
           <a:p>
             <a:fld id="{5BCAD085-E8A6-8845-BD4E-CB4CCA059FC4}" type="datetimeFigureOut">
               <a:rPr lang="en-US" smtClean="0"/>
-              <a:t>4/19/2026</a:t>
+              <a:t>4/25/2026</a:t>
             </a:fld>
             <a:endParaRPr lang="en-US"/>
           </a:p>
@@ -827,7 +827,7 @@
           <a:p>
             <a:fld id="{5BCAD085-E8A6-8845-BD4E-CB4CCA059FC4}" type="datetimeFigureOut">
               <a:rPr lang="en-US" smtClean="0"/>
-              <a:t>4/19/2026</a:t>
+              <a:t>4/25/2026</a:t>
             </a:fld>
             <a:endParaRPr lang="en-US"/>
           </a:p>
@@ -1072,7 +1072,7 @@
           <a:p>
             <a:fld id="{5BCAD085-E8A6-8845-BD4E-CB4CCA059FC4}" type="datetimeFigureOut">
               <a:rPr lang="en-US" smtClean="0"/>
-              <a:t>4/19/2026</a:t>
+              <a:t>4/25/2026</a:t>
             </a:fld>
             <a:endParaRPr lang="en-US"/>
           </a:p>
@@ -1357,7 +1357,7 @@
           <a:p>
             <a:fld id="{5BCAD085-E8A6-8845-BD4E-CB4CCA059FC4}" type="datetimeFigureOut">
               <a:rPr lang="en-US" smtClean="0"/>
-              <a:t>4/19/2026</a:t>
+              <a:t>4/25/2026</a:t>
             </a:fld>
             <a:endParaRPr lang="en-US"/>
           </a:p>
@@ -1776,7 +1776,7 @@
           <a:p>
             <a:fld id="{5BCAD085-E8A6-8845-BD4E-CB4CCA059FC4}" type="datetimeFigureOut">
               <a:rPr lang="en-US" smtClean="0"/>
-              <a:t>4/19/2026</a:t>
+              <a:t>4/25/2026</a:t>
             </a:fld>
             <a:endParaRPr lang="en-US"/>
           </a:p>
@@ -1893,7 +1893,7 @@
           <a:p>
             <a:fld id="{5BCAD085-E8A6-8845-BD4E-CB4CCA059FC4}" type="datetimeFigureOut">
               <a:rPr lang="en-US" smtClean="0"/>
-              <a:t>4/19/2026</a:t>
+              <a:t>4/25/2026</a:t>
             </a:fld>
             <a:endParaRPr lang="en-US"/>
           </a:p>
@@ -1988,7 +1988,7 @@
           <a:p>
             <a:fld id="{5BCAD085-E8A6-8845-BD4E-CB4CCA059FC4}" type="datetimeFigureOut">
               <a:rPr lang="en-US" smtClean="0"/>
-              <a:t>4/19/2026</a:t>
+              <a:t>4/25/2026</a:t>
             </a:fld>
             <a:endParaRPr lang="en-US"/>
           </a:p>
@@ -2263,7 +2263,7 @@
           <a:p>
             <a:fld id="{5BCAD085-E8A6-8845-BD4E-CB4CCA059FC4}" type="datetimeFigureOut">
               <a:rPr lang="en-US" smtClean="0"/>
-              <a:t>4/19/2026</a:t>
+              <a:t>4/25/2026</a:t>
             </a:fld>
             <a:endParaRPr lang="en-US"/>
           </a:p>
@@ -2515,7 +2515,7 @@
           <a:p>
             <a:fld id="{5BCAD085-E8A6-8845-BD4E-CB4CCA059FC4}" type="datetimeFigureOut">
               <a:rPr lang="en-US" smtClean="0"/>
-              <a:t>4/19/2026</a:t>
+              <a:t>4/25/2026</a:t>
             </a:fld>
             <a:endParaRPr lang="en-US"/>
           </a:p>
@@ -2726,7 +2726,7 @@
           <a:p>
             <a:fld id="{5BCAD085-E8A6-8845-BD4E-CB4CCA059FC4}" type="datetimeFigureOut">
               <a:rPr lang="en-US" smtClean="0"/>
-              <a:t>4/19/2026</a:t>
+              <a:t>4/25/2026</a:t>
             </a:fld>
             <a:endParaRPr lang="en-US"/>
           </a:p>
@@ -3718,28 +3718,33 @@
         <p:spPr>
           <a:xfrm>
             <a:off x="640080" y="6217920"/>
-            <a:ext cx="10881360" cy="457200"/>
-          </a:xfrm>
-          <a:prstGeom prst="rect">
-            <a:avLst/>
-          </a:prstGeom>
-          <a:noFill/>
-        </p:spPr>
-        <p:txBody>
-          <a:bodyPr wrap="square">
-            <a:spAutoFit/>
-          </a:bodyPr>
-          <a:lstStyle/>
-          <a:p>
-            <a:pPr algn="ctr"/>
-            <a:r>
-              <a:rPr sz="1400" b="0">
+            <a:ext cx="10881360" cy="307777"/>
+          </a:xfrm>
+          <a:prstGeom prst="rect">
+            <a:avLst/>
+          </a:prstGeom>
+          <a:noFill/>
+        </p:spPr>
+        <p:txBody>
+          <a:bodyPr wrap="square">
+            <a:spAutoFit/>
+          </a:bodyPr>
+          <a:lstStyle/>
+          <a:p>
+            <a:pPr algn="ctr"/>
+            <a:r>
+              <a:rPr lang="en-US" sz="1400" dirty="0">
                 <a:solidFill>
                   <a:srgbClr val="8888AA"/>
                 </a:solidFill>
               </a:rPr>
-              <a:t>Applied Intelligent Deep Learning  |  2026</a:t>
-            </a:r>
+              <a:t>Joshua Godwin, Chayasri Kirankumar, Bansari Yadav</a:t>
+            </a:r>
+            <a:endParaRPr sz="1400" b="0" dirty="0">
+              <a:solidFill>
+                <a:srgbClr val="8888AA"/>
+              </a:solidFill>
+            </a:endParaRPr>
           </a:p>
         </p:txBody>
       </p:sp>
@@ -6761,28 +6766,33 @@
         <p:spPr>
           <a:xfrm>
             <a:off x="640080" y="6263640"/>
-            <a:ext cx="10881360" cy="411480"/>
-          </a:xfrm>
-          <a:prstGeom prst="rect">
-            <a:avLst/>
-          </a:prstGeom>
-          <a:noFill/>
-        </p:spPr>
-        <p:txBody>
-          <a:bodyPr wrap="square">
-            <a:spAutoFit/>
-          </a:bodyPr>
-          <a:lstStyle/>
-          <a:p>
-            <a:pPr algn="ctr"/>
-            <a:r>
-              <a:rPr sz="1400" b="0">
+            <a:ext cx="10881360" cy="307777"/>
+          </a:xfrm>
+          <a:prstGeom prst="rect">
+            <a:avLst/>
+          </a:prstGeom>
+          <a:noFill/>
+        </p:spPr>
+        <p:txBody>
+          <a:bodyPr wrap="square">
+            <a:spAutoFit/>
+          </a:bodyPr>
+          <a:lstStyle/>
+          <a:p>
+            <a:pPr algn="ctr"/>
+            <a:r>
+              <a:rPr lang="en-US" sz="1400">
                 <a:solidFill>
                   <a:srgbClr val="667799"/>
                 </a:solidFill>
               </a:rPr>
-              <a:t>Applied Intelligent Deep Learning  |  2026</a:t>
-            </a:r>
+              <a:t>Joshua Godwin, Chayasri Kirankumar, Bansari Yadav</a:t>
+            </a:r>
+            <a:endParaRPr sz="1400" b="0" dirty="0">
+              <a:solidFill>
+                <a:srgbClr val="667799"/>
+              </a:solidFill>
+            </a:endParaRPr>
           </a:p>
         </p:txBody>
       </p:sp>

</xml_diff>